<commit_message>
Add demo video link and update presentation
</commit_message>
<xml_diff>
--- a/RVCE_MergeMind.pptx
+++ b/RVCE_MergeMind.pptx
@@ -5954,7 +5954,7 @@
         <p:spPr>
           <a:xfrm>
             <a:off x="609600" y="1841178"/>
-            <a:ext cx="5570547" cy="369332"/>
+            <a:ext cx="5570547" cy="1200329"/>
           </a:xfrm>
           <a:prstGeom prst="rect">
             <a:avLst/>
@@ -5972,6 +5972,24 @@
                 <a:hlinkClick r:id="rId3"/>
               </a:rPr>
               <a:t>https://github.com/rxchitrx/openclaw-mesh-extension</a:t>
+            </a:r>
+            <a:br>
+              <a:rPr lang="en-US" dirty="0"/>
+            </a:br>
+            <a:br>
+              <a:rPr lang="en-US" dirty="0"/>
+            </a:br>
+            <a:r>
+              <a:rPr lang="en-US" dirty="0"/>
+              <a:t>https://</a:t>
+            </a:r>
+            <a:r>
+              <a:rPr lang="en-US" dirty="0" err="1"/>
+              <a:t>drive.google.com</a:t>
+            </a:r>
+            <a:r>
+              <a:rPr lang="en-US" dirty="0"/>
+              <a:t>/drive/folders/1h6EmILlajb08m-4zhbxEZOVtthdrEanX?usp=sharing</a:t>
             </a:r>
             <a:endParaRPr lang="en-IN" dirty="0"/>
           </a:p>

</xml_diff>